<commit_message>
Update blog content and styling
</commit_message>
<xml_diff>
--- a/99ref/blog.pptx
+++ b/99ref/blog.pptx
@@ -5,11 +5,12 @@
     <p:sldMasterId id="2147483672" r:id="rId1"/>
   </p:sldMasterIdLst>
   <p:sldIdLst>
-    <p:sldId id="256" r:id="rId2"/>
-    <p:sldId id="257" r:id="rId3"/>
-    <p:sldId id="258" r:id="rId4"/>
-    <p:sldId id="259" r:id="rId5"/>
-    <p:sldId id="260" r:id="rId6"/>
+    <p:sldId id="261" r:id="rId2"/>
+    <p:sldId id="256" r:id="rId3"/>
+    <p:sldId id="257" r:id="rId4"/>
+    <p:sldId id="258" r:id="rId5"/>
+    <p:sldId id="259" r:id="rId6"/>
+    <p:sldId id="260" r:id="rId7"/>
   </p:sldIdLst>
   <p:sldSz cx="9720263" cy="8999538"/>
   <p:notesSz cx="6858000" cy="9144000"/>
@@ -3066,7 +3067,7 @@
         </p:nvSpPr>
         <p:spPr>
           <a:xfrm>
-            <a:off x="161471" y="493486"/>
+            <a:off x="161471" y="556986"/>
             <a:ext cx="9312729" cy="497114"/>
           </a:xfrm>
           <a:prstGeom prst="rect">
@@ -3195,7 +3196,7 @@
         </p:nvSpPr>
         <p:spPr>
           <a:xfrm>
-            <a:off x="516056" y="2559824"/>
+            <a:off x="516056" y="2699524"/>
             <a:ext cx="2129255" cy="244298"/>
           </a:xfrm>
           <a:prstGeom prst="rect">
@@ -3252,7 +3253,7 @@
         </p:blipFill>
         <p:spPr>
           <a:xfrm>
-            <a:off x="950683" y="1077680"/>
+            <a:off x="950683" y="1179280"/>
             <a:ext cx="1260000" cy="1260000"/>
           </a:xfrm>
           <a:prstGeom prst="rect">
@@ -3271,7 +3272,7 @@
         </p:nvSpPr>
         <p:spPr>
           <a:xfrm>
-            <a:off x="140683" y="3026267"/>
+            <a:off x="140683" y="3204067"/>
             <a:ext cx="2880000" cy="1406154"/>
           </a:xfrm>
           <a:prstGeom prst="rect">
@@ -4159,7 +4160,7 @@
         </p:nvSpPr>
         <p:spPr>
           <a:xfrm>
-            <a:off x="3410947" y="2567944"/>
+            <a:off x="3410947" y="2707644"/>
             <a:ext cx="2892462" cy="244298"/>
           </a:xfrm>
           <a:prstGeom prst="rect">
@@ -4216,7 +4217,7 @@
         </p:blipFill>
         <p:spPr>
           <a:xfrm>
-            <a:off x="4227178" y="1119660"/>
+            <a:off x="4227178" y="1221260"/>
             <a:ext cx="1260000" cy="1260000"/>
           </a:xfrm>
           <a:prstGeom prst="rect">
@@ -4235,7 +4236,7 @@
         </p:nvSpPr>
         <p:spPr>
           <a:xfrm>
-            <a:off x="3417178" y="3029554"/>
+            <a:off x="3417178" y="3207354"/>
             <a:ext cx="2880000" cy="1406154"/>
           </a:xfrm>
           <a:prstGeom prst="rect">
@@ -5128,7 +5129,7 @@
         </p:nvSpPr>
         <p:spPr>
           <a:xfrm>
-            <a:off x="7048799" y="2617551"/>
+            <a:off x="7048799" y="2757251"/>
             <a:ext cx="2169750" cy="244298"/>
           </a:xfrm>
           <a:prstGeom prst="rect">
@@ -5185,7 +5186,7 @@
         </p:blipFill>
         <p:spPr>
           <a:xfrm>
-            <a:off x="7503674" y="1155267"/>
+            <a:off x="7503674" y="1256867"/>
             <a:ext cx="1260000" cy="1260000"/>
           </a:xfrm>
           <a:prstGeom prst="rect">
@@ -5204,7 +5205,7 @@
         </p:nvSpPr>
         <p:spPr>
           <a:xfrm>
-            <a:off x="6693674" y="3064133"/>
+            <a:off x="6693674" y="3241933"/>
             <a:ext cx="2820440" cy="1186222"/>
           </a:xfrm>
           <a:prstGeom prst="rect">
@@ -6050,6 +6051,78 @@
           </a:p>
         </p:txBody>
       </p:sp>
+      <p:cxnSp>
+        <p:nvCxnSpPr>
+          <p:cNvPr id="3" name="직선 연결선 2"/>
+          <p:cNvCxnSpPr/>
+          <p:nvPr/>
+        </p:nvCxnSpPr>
+        <p:spPr>
+          <a:xfrm flipV="1">
+            <a:off x="215900" y="495300"/>
+            <a:ext cx="9156700" cy="0"/>
+          </a:xfrm>
+          <a:prstGeom prst="line">
+            <a:avLst/>
+          </a:prstGeom>
+          <a:ln w="19050">
+            <a:solidFill>
+              <a:schemeClr val="accent1"/>
+            </a:solidFill>
+          </a:ln>
+        </p:spPr>
+        <p:style>
+          <a:lnRef idx="1">
+            <a:schemeClr val="accent1"/>
+          </a:lnRef>
+          <a:fillRef idx="0">
+            <a:schemeClr val="accent1"/>
+          </a:fillRef>
+          <a:effectRef idx="0">
+            <a:schemeClr val="accent1"/>
+          </a:effectRef>
+          <a:fontRef idx="minor">
+            <a:schemeClr val="tx1"/>
+          </a:fontRef>
+        </p:style>
+      </p:cxnSp>
+    </p:spTree>
+    <p:extLst>
+      <p:ext uri="{BB962C8B-B14F-4D97-AF65-F5344CB8AC3E}">
+        <p14:creationId xmlns:p14="http://schemas.microsoft.com/office/powerpoint/2010/main" val="3647370395"/>
+      </p:ext>
+    </p:extLst>
+  </p:cSld>
+  <p:clrMapOvr>
+    <a:masterClrMapping/>
+  </p:clrMapOvr>
+  <p:timing>
+    <p:tnLst>
+      <p:par>
+        <p:cTn id="1" dur="indefinite" restart="never" nodeType="tmRoot"/>
+      </p:par>
+    </p:tnLst>
+  </p:timing>
+</p:sld>
+</file>
+
+<file path=ppt/slides/slide2.xml><?xml version="1.0" encoding="utf-8"?>
+<p:sld xmlns:a="http://schemas.openxmlformats.org/drawingml/2006/main" xmlns:r="http://schemas.openxmlformats.org/officeDocument/2006/relationships" xmlns:p="http://schemas.openxmlformats.org/presentationml/2006/main">
+  <p:cSld>
+    <p:spTree>
+      <p:nvGrpSpPr>
+        <p:cNvPr id="1" name=""/>
+        <p:cNvGrpSpPr/>
+        <p:nvPr/>
+      </p:nvGrpSpPr>
+      <p:grpSpPr>
+        <a:xfrm>
+          <a:off x="0" y="0"/>
+          <a:ext cx="0" cy="0"/>
+          <a:chOff x="0" y="0"/>
+          <a:chExt cx="0" cy="0"/>
+        </a:xfrm>
+      </p:grpSpPr>
       <p:sp>
         <p:nvSpPr>
           <p:cNvPr id="14" name="직사각형 13"/>
@@ -6058,7 +6131,7 @@
         </p:nvSpPr>
         <p:spPr>
           <a:xfrm>
-            <a:off x="0" y="4417787"/>
+            <a:off x="0" y="36287"/>
             <a:ext cx="2186829" cy="312964"/>
           </a:xfrm>
           <a:prstGeom prst="rect">
@@ -6152,7 +6225,7 @@
         </p:nvSpPr>
         <p:spPr>
           <a:xfrm>
-            <a:off x="9071" y="4760686"/>
+            <a:off x="9071" y="455386"/>
             <a:ext cx="9873546" cy="497114"/>
           </a:xfrm>
           <a:prstGeom prst="rect">
@@ -6246,13 +6319,13 @@
           <p:nvPr>
             <p:extLst>
               <p:ext uri="{D42A27DB-BD31-4B8C-83A1-F6EECF244321}">
-                <p14:modId xmlns:p14="http://schemas.microsoft.com/office/powerpoint/2010/main" val="1735461271"/>
+                <p14:modId xmlns:p14="http://schemas.microsoft.com/office/powerpoint/2010/main" val="697670764"/>
               </p:ext>
             </p:extLst>
           </p:nvPr>
         </p:nvGraphicFramePr>
         <p:xfrm>
-          <a:off x="246308" y="5458187"/>
+          <a:off x="854318" y="1323204"/>
           <a:ext cx="200863" cy="1310940"/>
         </p:xfrm>
         <a:graphic>
@@ -6403,13 +6476,13 @@
           <p:nvPr>
             <p:extLst>
               <p:ext uri="{D42A27DB-BD31-4B8C-83A1-F6EECF244321}">
-                <p14:modId xmlns:p14="http://schemas.microsoft.com/office/powerpoint/2010/main" val="601713452"/>
+                <p14:modId xmlns:p14="http://schemas.microsoft.com/office/powerpoint/2010/main" val="1186017447"/>
               </p:ext>
             </p:extLst>
           </p:nvPr>
         </p:nvGraphicFramePr>
         <p:xfrm>
-          <a:off x="516052" y="5458187"/>
+          <a:off x="1124062" y="1323204"/>
           <a:ext cx="200863" cy="1310940"/>
         </p:xfrm>
         <a:graphic>
@@ -6545,13 +6618,13 @@
           <p:nvPr>
             <p:extLst>
               <p:ext uri="{D42A27DB-BD31-4B8C-83A1-F6EECF244321}">
-                <p14:modId xmlns:p14="http://schemas.microsoft.com/office/powerpoint/2010/main" val="3706800928"/>
+                <p14:modId xmlns:p14="http://schemas.microsoft.com/office/powerpoint/2010/main" val="906202153"/>
               </p:ext>
             </p:extLst>
           </p:nvPr>
         </p:nvGraphicFramePr>
         <p:xfrm>
-          <a:off x="761055" y="5458187"/>
+          <a:off x="1430594" y="1323204"/>
           <a:ext cx="200863" cy="1310940"/>
         </p:xfrm>
         <a:graphic>
@@ -6697,13 +6770,13 @@
           <p:nvPr>
             <p:extLst>
               <p:ext uri="{D42A27DB-BD31-4B8C-83A1-F6EECF244321}">
-                <p14:modId xmlns:p14="http://schemas.microsoft.com/office/powerpoint/2010/main" val="3336143817"/>
+                <p14:modId xmlns:p14="http://schemas.microsoft.com/office/powerpoint/2010/main" val="2359857303"/>
               </p:ext>
             </p:extLst>
           </p:nvPr>
         </p:nvGraphicFramePr>
         <p:xfrm>
-          <a:off x="995218" y="5458187"/>
+          <a:off x="1710385" y="1323204"/>
           <a:ext cx="200863" cy="1310940"/>
         </p:xfrm>
         <a:graphic>
@@ -6854,13 +6927,13 @@
           <p:nvPr>
             <p:extLst>
               <p:ext uri="{D42A27DB-BD31-4B8C-83A1-F6EECF244321}">
-                <p14:modId xmlns:p14="http://schemas.microsoft.com/office/powerpoint/2010/main" val="1728891744"/>
+                <p14:modId xmlns:p14="http://schemas.microsoft.com/office/powerpoint/2010/main" val="219103042"/>
               </p:ext>
             </p:extLst>
           </p:nvPr>
         </p:nvGraphicFramePr>
         <p:xfrm>
-          <a:off x="1258304" y="5459907"/>
+          <a:off x="1973471" y="1324064"/>
           <a:ext cx="199782" cy="1309220"/>
         </p:xfrm>
         <a:graphic>
@@ -7010,7 +7083,7 @@
         </p:nvCxnSpPr>
         <p:spPr>
           <a:xfrm flipH="1">
-            <a:off x="337563" y="5682153"/>
+            <a:off x="945573" y="1435187"/>
             <a:ext cx="2" cy="1086974"/>
           </a:xfrm>
           <a:prstGeom prst="straightConnector1">
@@ -7047,7 +7120,7 @@
         </p:nvGrpSpPr>
         <p:grpSpPr>
           <a:xfrm>
-            <a:off x="7917832" y="5542849"/>
+            <a:off x="7436328" y="1309491"/>
             <a:ext cx="1546355" cy="1226278"/>
             <a:chOff x="8060037" y="1837974"/>
             <a:chExt cx="1458522" cy="1305922"/>
@@ -7709,7 +7782,7 @@
         </p:nvGrpSpPr>
         <p:grpSpPr>
           <a:xfrm>
-            <a:off x="3971921" y="5639579"/>
+            <a:off x="7595813" y="4467874"/>
             <a:ext cx="1298777" cy="1129548"/>
             <a:chOff x="1392799" y="8552193"/>
             <a:chExt cx="285312" cy="263081"/>
@@ -9140,7 +9213,7 @@
         </p:nvSpPr>
         <p:spPr bwMode="auto">
           <a:xfrm>
-            <a:off x="2173506" y="5499926"/>
+            <a:off x="4511584" y="1344074"/>
             <a:ext cx="1038585" cy="1269201"/>
           </a:xfrm>
           <a:custGeom>
@@ -10380,7 +10453,7 @@
         </p:nvSpPr>
         <p:spPr>
           <a:xfrm>
-            <a:off x="99782" y="6984368"/>
+            <a:off x="731750" y="2755268"/>
             <a:ext cx="1603053" cy="504000"/>
           </a:xfrm>
           <a:prstGeom prst="rect">
@@ -10446,7 +10519,7 @@
         </p:nvSpPr>
         <p:spPr>
           <a:xfrm>
-            <a:off x="2047610" y="6984368"/>
+            <a:off x="4229350" y="2755268"/>
             <a:ext cx="1603053" cy="504000"/>
           </a:xfrm>
           <a:prstGeom prst="rect">
@@ -10512,7 +10585,7 @@
         </p:nvSpPr>
         <p:spPr>
           <a:xfrm>
-            <a:off x="3995438" y="6984368"/>
+            <a:off x="7443675" y="5752338"/>
             <a:ext cx="1603053" cy="504000"/>
           </a:xfrm>
           <a:prstGeom prst="rect">
@@ -10566,7 +10639,7 @@
         </p:nvSpPr>
         <p:spPr>
           <a:xfrm>
-            <a:off x="5943266" y="6984368"/>
+            <a:off x="731750" y="5752338"/>
             <a:ext cx="1603053" cy="504000"/>
           </a:xfrm>
           <a:prstGeom prst="rect">
@@ -10620,7 +10693,7 @@
         </p:nvSpPr>
         <p:spPr>
           <a:xfrm>
-            <a:off x="7891093" y="6984368"/>
+            <a:off x="7407979" y="2682697"/>
             <a:ext cx="1603053" cy="504000"/>
           </a:xfrm>
           <a:prstGeom prst="rect">
@@ -10674,8 +10747,8 @@
         </p:nvSpPr>
         <p:spPr>
           <a:xfrm>
-            <a:off x="42829" y="7586979"/>
-            <a:ext cx="1723822" cy="382541"/>
+            <a:off x="125076" y="3368765"/>
+            <a:ext cx="2808000" cy="400622"/>
           </a:xfrm>
           <a:prstGeom prst="rect">
             <a:avLst/>
@@ -10747,8 +10820,8 @@
         </p:nvSpPr>
         <p:spPr>
           <a:xfrm>
-            <a:off x="1880579" y="7586979"/>
-            <a:ext cx="1498137" cy="594522"/>
+            <a:off x="3622676" y="3368765"/>
+            <a:ext cx="2808000" cy="400622"/>
           </a:xfrm>
           <a:prstGeom prst="rect">
             <a:avLst/>
@@ -10834,8 +10907,8 @@
         </p:nvSpPr>
         <p:spPr>
           <a:xfrm>
-            <a:off x="3721113" y="7597865"/>
-            <a:ext cx="1830601" cy="1370119"/>
+            <a:off x="6815230" y="6365835"/>
+            <a:ext cx="2808000" cy="788421"/>
           </a:xfrm>
           <a:prstGeom prst="rect">
             <a:avLst/>
@@ -10982,7 +11055,28 @@
                 <a:latin typeface="+mn-ea"/>
                 <a:cs typeface="Pretendard Variable Medium" panose="02000003000000020004" pitchFamily="2" charset="-127"/>
               </a:rPr>
-              <a:t>수준의 확장성 제공</a:t>
+              <a:t>수준의 </a:t>
+            </a:r>
+            <a:r>
+              <a:rPr lang="ko-KR" altLang="en-US" sz="1050" dirty="0" err="1">
+                <a:latin typeface="+mn-ea"/>
+                <a:cs typeface="Pretendard Variable Medium" panose="02000003000000020004" pitchFamily="2" charset="-127"/>
+              </a:rPr>
+              <a:t>확장성</a:t>
+            </a:r>
+            <a:r>
+              <a:rPr lang="ko-KR" altLang="en-US" sz="1050" dirty="0">
+                <a:latin typeface="+mn-ea"/>
+                <a:cs typeface="Pretendard Variable Medium" panose="02000003000000020004" pitchFamily="2" charset="-127"/>
+              </a:rPr>
+              <a:t> </a:t>
+            </a:r>
+            <a:r>
+              <a:rPr lang="ko-KR" altLang="en-US" sz="1050" dirty="0" smtClean="0">
+                <a:latin typeface="+mn-ea"/>
+                <a:cs typeface="Pretendard Variable Medium" panose="02000003000000020004" pitchFamily="2" charset="-127"/>
+              </a:rPr>
+              <a:t>제공</a:t>
             </a:r>
             <a:endParaRPr lang="en-US" altLang="ko-KR" sz="1050" dirty="0">
               <a:latin typeface="+mn-ea"/>
@@ -10999,8 +11093,8 @@
         </p:nvSpPr>
         <p:spPr>
           <a:xfrm>
-            <a:off x="5907535" y="7586979"/>
-            <a:ext cx="1749145" cy="381515"/>
+            <a:off x="144076" y="6365835"/>
+            <a:ext cx="2808000" cy="381515"/>
           </a:xfrm>
           <a:prstGeom prst="rect">
             <a:avLst/>
@@ -11058,8 +11152,8 @@
         </p:nvSpPr>
         <p:spPr>
           <a:xfrm>
-            <a:off x="7822196" y="7586979"/>
-            <a:ext cx="1749145" cy="594522"/>
+            <a:off x="6820305" y="3372394"/>
+            <a:ext cx="2808000" cy="594522"/>
           </a:xfrm>
           <a:prstGeom prst="rect">
             <a:avLst/>
@@ -11145,7 +11239,7 @@
         </p:nvGrpSpPr>
         <p:grpSpPr>
           <a:xfrm rot="18900000">
-            <a:off x="6078731" y="5563601"/>
+            <a:off x="885276" y="4453258"/>
             <a:ext cx="1296000" cy="1296000"/>
             <a:chOff x="7135913" y="1248230"/>
             <a:chExt cx="1851539" cy="1832402"/>
@@ -13872,13 +13966,13 @@
       </p:grpSp>
       <p:cxnSp>
         <p:nvCxnSpPr>
-          <p:cNvPr id="3" name="직선 연결선 2"/>
+          <p:cNvPr id="76" name="직선 연결선 75"/>
           <p:cNvCxnSpPr/>
           <p:nvPr/>
         </p:nvCxnSpPr>
         <p:spPr>
           <a:xfrm flipV="1">
-            <a:off x="215900" y="469900"/>
+            <a:off x="114300" y="393700"/>
             <a:ext cx="9156700" cy="0"/>
           </a:xfrm>
           <a:prstGeom prst="line">
@@ -13905,41 +13999,521 @@
           </a:fontRef>
         </p:style>
       </p:cxnSp>
-      <p:cxnSp>
-        <p:nvCxnSpPr>
-          <p:cNvPr id="76" name="직선 연결선 75"/>
-          <p:cNvCxnSpPr/>
+      <p:sp>
+        <p:nvSpPr>
+          <p:cNvPr id="85" name="Rectangle 99"/>
+          <p:cNvSpPr/>
           <p:nvPr/>
-        </p:nvCxnSpPr>
+        </p:nvSpPr>
         <p:spPr>
-          <a:xfrm flipV="1">
-            <a:off x="114300" y="4775200"/>
-            <a:ext cx="9156700" cy="0"/>
+          <a:xfrm>
+            <a:off x="4265046" y="5752338"/>
+            <a:ext cx="1603053" cy="504000"/>
           </a:xfrm>
-          <a:prstGeom prst="line">
+          <a:prstGeom prst="rect">
             <a:avLst/>
           </a:prstGeom>
-          <a:ln w="19050">
-            <a:solidFill>
-              <a:schemeClr val="accent1"/>
-            </a:solidFill>
+          <a:solidFill>
+            <a:srgbClr val="0B3D84"/>
+          </a:solidFill>
+          <a:ln>
+            <a:noFill/>
           </a:ln>
         </p:spPr>
         <p:style>
-          <a:lnRef idx="1">
-            <a:schemeClr val="accent1"/>
+          <a:lnRef idx="2">
+            <a:schemeClr val="accent1">
+              <a:shade val="50000"/>
+            </a:schemeClr>
           </a:lnRef>
-          <a:fillRef idx="0">
+          <a:fillRef idx="1">
             <a:schemeClr val="accent1"/>
           </a:fillRef>
           <a:effectRef idx="0">
             <a:schemeClr val="accent1"/>
           </a:effectRef>
           <a:fontRef idx="minor">
-            <a:schemeClr val="tx1"/>
+            <a:schemeClr val="lt1"/>
           </a:fontRef>
         </p:style>
-      </p:cxnSp>
+        <p:txBody>
+          <a:bodyPr tIns="0" bIns="0" rtlCol="0" anchor="ctr"/>
+          <a:lstStyle/>
+          <a:p>
+            <a:pPr algn="ctr"/>
+            <a:r>
+              <a:rPr lang="en-US" sz="1200" b="1" dirty="0" smtClean="0">
+                <a:solidFill>
+                  <a:schemeClr val="bg1"/>
+                </a:solidFill>
+                <a:latin typeface="+mn-ea"/>
+              </a:rPr>
+              <a:t>MCP</a:t>
+            </a:r>
+            <a:r>
+              <a:rPr lang="en-US" sz="1200" b="1" dirty="0">
+                <a:solidFill>
+                  <a:schemeClr val="bg1"/>
+                </a:solidFill>
+                <a:latin typeface="+mn-ea"/>
+              </a:rPr>
+              <a:t> </a:t>
+            </a:r>
+            <a:r>
+              <a:rPr lang="en-US" sz="1200" b="1" dirty="0" err="1" smtClean="0">
+                <a:solidFill>
+                  <a:schemeClr val="bg1"/>
+                </a:solidFill>
+                <a:latin typeface="+mn-ea"/>
+              </a:rPr>
+              <a:t>Intergration</a:t>
+            </a:r>
+            <a:endParaRPr lang="en-US" sz="1200" b="1" dirty="0">
+              <a:solidFill>
+                <a:schemeClr val="bg1"/>
+              </a:solidFill>
+              <a:latin typeface="+mn-ea"/>
+            </a:endParaRPr>
+          </a:p>
+        </p:txBody>
+      </p:sp>
+      <p:sp>
+        <p:nvSpPr>
+          <p:cNvPr id="86" name="object 10"/>
+          <p:cNvSpPr txBox="1"/>
+          <p:nvPr/>
+        </p:nvSpPr>
+        <p:spPr>
+          <a:xfrm>
+            <a:off x="3677372" y="6365835"/>
+            <a:ext cx="2808000" cy="982320"/>
+          </a:xfrm>
+          <a:prstGeom prst="rect">
+            <a:avLst/>
+          </a:prstGeom>
+        </p:spPr>
+        <p:txBody>
+          <a:bodyPr vert="horz" wrap="square" lIns="0" tIns="12700" rIns="0" bIns="0" rtlCol="0">
+            <a:spAutoFit/>
+          </a:bodyPr>
+          <a:lstStyle/>
+          <a:p>
+            <a:pPr marL="180975" indent="-180975">
+              <a:lnSpc>
+                <a:spcPct val="120000"/>
+              </a:lnSpc>
+              <a:buClr>
+                <a:srgbClr val="1668C1"/>
+              </a:buClr>
+              <a:buFont typeface="Arial" panose="020B0604020202020204" pitchFamily="34" charset="0"/>
+              <a:buChar char="•"/>
+            </a:pPr>
+            <a:r>
+              <a:rPr lang="en-US" altLang="ko-KR" sz="1050" dirty="0" smtClean="0">
+                <a:latin typeface="+mn-ea"/>
+                <a:cs typeface="Pretendard Variable Medium" panose="02000003000000020004" pitchFamily="2" charset="-127"/>
+              </a:rPr>
+              <a:t>MCP </a:t>
+            </a:r>
+            <a:r>
+              <a:rPr lang="ko-KR" altLang="en-US" sz="1050" dirty="0" smtClean="0">
+                <a:latin typeface="+mn-ea"/>
+                <a:cs typeface="Pretendard Variable Medium" panose="02000003000000020004" pitchFamily="2" charset="-127"/>
+              </a:rPr>
+              <a:t>기반 자연어 질의 지원으로 </a:t>
+            </a:r>
+            <a:r>
+              <a:rPr lang="en-US" altLang="ko-KR" sz="1050" dirty="0" smtClean="0">
+                <a:latin typeface="+mn-ea"/>
+                <a:cs typeface="Pretendard Variable Medium" panose="02000003000000020004" pitchFamily="2" charset="-127"/>
+              </a:rPr>
+              <a:t>SQL</a:t>
+            </a:r>
+            <a:r>
+              <a:rPr lang="ko-KR" altLang="en-US" sz="1050" dirty="0" smtClean="0">
+                <a:latin typeface="+mn-ea"/>
+                <a:cs typeface="Pretendard Variable Medium" panose="02000003000000020004" pitchFamily="2" charset="-127"/>
+              </a:rPr>
+              <a:t>에 익숙하지 않은 사용자도 데이터 분석가능</a:t>
+            </a:r>
+            <a:endParaRPr lang="en-US" altLang="ko-KR" sz="1050" dirty="0" smtClean="0">
+              <a:latin typeface="+mn-ea"/>
+              <a:cs typeface="Pretendard Variable Medium" panose="02000003000000020004" pitchFamily="2" charset="-127"/>
+            </a:endParaRPr>
+          </a:p>
+          <a:p>
+            <a:pPr marL="180975" indent="-180975">
+              <a:lnSpc>
+                <a:spcPct val="120000"/>
+              </a:lnSpc>
+              <a:buClr>
+                <a:srgbClr val="1668C1"/>
+              </a:buClr>
+              <a:buFont typeface="Arial" panose="020B0604020202020204" pitchFamily="34" charset="0"/>
+              <a:buChar char="•"/>
+            </a:pPr>
+            <a:r>
+              <a:rPr lang="ko-KR" altLang="en-US" sz="1050" dirty="0" smtClean="0">
+                <a:latin typeface="+mn-ea"/>
+                <a:cs typeface="Pretendard Variable Medium" panose="02000003000000020004" pitchFamily="2" charset="-127"/>
+              </a:rPr>
+              <a:t>이미지</a:t>
+            </a:r>
+            <a:r>
+              <a:rPr lang="en-US" altLang="ko-KR" sz="1050" dirty="0" smtClean="0">
+                <a:latin typeface="+mn-ea"/>
+                <a:cs typeface="Pretendard Variable Medium" panose="02000003000000020004" pitchFamily="2" charset="-127"/>
+              </a:rPr>
+              <a:t>/ </a:t>
+            </a:r>
+            <a:r>
+              <a:rPr lang="ko-KR" altLang="en-US" sz="1050" dirty="0" smtClean="0">
+                <a:latin typeface="+mn-ea"/>
+                <a:cs typeface="Pretendard Variable Medium" panose="02000003000000020004" pitchFamily="2" charset="-127"/>
+              </a:rPr>
+              <a:t>비정형 데이터에 대한 고차원 </a:t>
+            </a:r>
+            <a:r>
+              <a:rPr lang="en-US" altLang="ko-KR" sz="1050" dirty="0" smtClean="0">
+                <a:latin typeface="+mn-ea"/>
+                <a:cs typeface="Pretendard Variable Medium" panose="02000003000000020004" pitchFamily="2" charset="-127"/>
+              </a:rPr>
+              <a:t>Vector Search </a:t>
+            </a:r>
+            <a:r>
+              <a:rPr lang="ko-KR" altLang="en-US" sz="1050" dirty="0" smtClean="0">
+                <a:latin typeface="+mn-ea"/>
+                <a:cs typeface="Pretendard Variable Medium" panose="02000003000000020004" pitchFamily="2" charset="-127"/>
+              </a:rPr>
+              <a:t>기능으로 유사도 기반 고속 검색 및 분석 가능</a:t>
+            </a:r>
+            <a:endParaRPr lang="en-US" altLang="ko-KR" sz="1050" dirty="0">
+              <a:latin typeface="+mn-ea"/>
+              <a:cs typeface="Pretendard Variable Medium" panose="02000003000000020004" pitchFamily="2" charset="-127"/>
+            </a:endParaRPr>
+          </a:p>
+        </p:txBody>
+      </p:sp>
+      <p:grpSp>
+        <p:nvGrpSpPr>
+          <p:cNvPr id="100" name="그룹 99"/>
+          <p:cNvGrpSpPr/>
+          <p:nvPr/>
+        </p:nvGrpSpPr>
+        <p:grpSpPr>
+          <a:xfrm>
+            <a:off x="4420856" y="4565847"/>
+            <a:ext cx="1296865" cy="1045583"/>
+            <a:chOff x="7561385" y="4865070"/>
+            <a:chExt cx="1363620" cy="1045583"/>
+          </a:xfrm>
+        </p:grpSpPr>
+        <p:grpSp>
+          <p:nvGrpSpPr>
+            <p:cNvPr id="96" name="그룹 95"/>
+            <p:cNvGrpSpPr/>
+            <p:nvPr/>
+          </p:nvGrpSpPr>
+          <p:grpSpPr>
+            <a:xfrm>
+              <a:off x="7561385" y="4865070"/>
+              <a:ext cx="1090245" cy="689287"/>
+              <a:chOff x="7408985" y="4888525"/>
+              <a:chExt cx="855784" cy="505613"/>
+            </a:xfrm>
+          </p:grpSpPr>
+          <p:sp>
+            <p:nvSpPr>
+              <p:cNvPr id="5" name="모서리가 둥근 사각형 설명선 4"/>
+              <p:cNvSpPr/>
+              <p:nvPr/>
+            </p:nvSpPr>
+            <p:spPr>
+              <a:xfrm>
+                <a:off x="7432430" y="4888525"/>
+                <a:ext cx="797171" cy="480646"/>
+              </a:xfrm>
+              <a:prstGeom prst="wedgeRoundRectCallout">
+                <a:avLst>
+                  <a:gd name="adj1" fmla="val -38392"/>
+                  <a:gd name="adj2" fmla="val 90421"/>
+                  <a:gd name="adj3" fmla="val 16667"/>
+                </a:avLst>
+              </a:prstGeom>
+              <a:noFill/>
+              <a:ln w="38100">
+                <a:solidFill>
+                  <a:srgbClr val="9BB9FE"/>
+                </a:solidFill>
+              </a:ln>
+            </p:spPr>
+            <p:style>
+              <a:lnRef idx="2">
+                <a:schemeClr val="accent1">
+                  <a:shade val="50000"/>
+                </a:schemeClr>
+              </a:lnRef>
+              <a:fillRef idx="1">
+                <a:schemeClr val="accent1"/>
+              </a:fillRef>
+              <a:effectRef idx="0">
+                <a:schemeClr val="accent1"/>
+              </a:effectRef>
+              <a:fontRef idx="minor">
+                <a:schemeClr val="lt1"/>
+              </a:fontRef>
+            </p:style>
+            <p:txBody>
+              <a:bodyPr rtlCol="0" anchor="b"/>
+              <a:lstStyle/>
+              <a:p>
+                <a:pPr algn="ctr">
+                  <a:lnSpc>
+                    <a:spcPct val="30000"/>
+                  </a:lnSpc>
+                </a:pPr>
+                <a:endParaRPr lang="en-US" altLang="ko-KR" sz="2400" b="1" dirty="0">
+                  <a:solidFill>
+                    <a:srgbClr val="9BB9FE"/>
+                  </a:solidFill>
+                </a:endParaRPr>
+              </a:p>
+            </p:txBody>
+          </p:sp>
+          <p:sp>
+            <p:nvSpPr>
+              <p:cNvPr id="94" name="TextBox 93"/>
+              <p:cNvSpPr txBox="1"/>
+              <p:nvPr/>
+            </p:nvSpPr>
+            <p:spPr>
+              <a:xfrm>
+                <a:off x="7408985" y="4948913"/>
+                <a:ext cx="855784" cy="445225"/>
+              </a:xfrm>
+              <a:prstGeom prst="rect">
+                <a:avLst/>
+              </a:prstGeom>
+              <a:noFill/>
+            </p:spPr>
+            <p:txBody>
+              <a:bodyPr wrap="square" rtlCol="0" anchor="b">
+                <a:spAutoFit/>
+              </a:bodyPr>
+              <a:lstStyle/>
+              <a:p>
+                <a:pPr algn="ctr">
+                  <a:lnSpc>
+                    <a:spcPct val="30000"/>
+                  </a:lnSpc>
+                </a:pPr>
+                <a:r>
+                  <a:rPr lang="en-US" altLang="ko-KR" sz="3600" b="1" dirty="0">
+                    <a:solidFill>
+                      <a:srgbClr val="9BB9FE"/>
+                    </a:solidFill>
+                  </a:rPr>
+                  <a:t>-----</a:t>
+                </a:r>
+              </a:p>
+              <a:p>
+                <a:pPr algn="ctr">
+                  <a:lnSpc>
+                    <a:spcPct val="30000"/>
+                  </a:lnSpc>
+                </a:pPr>
+                <a:r>
+                  <a:rPr lang="en-US" altLang="ko-KR" sz="3600" b="1" dirty="0">
+                    <a:solidFill>
+                      <a:srgbClr val="9BB9FE"/>
+                    </a:solidFill>
+                  </a:rPr>
+                  <a:t>-----</a:t>
+                </a:r>
+              </a:p>
+              <a:p>
+                <a:pPr algn="ctr">
+                  <a:lnSpc>
+                    <a:spcPct val="30000"/>
+                  </a:lnSpc>
+                </a:pPr>
+                <a:r>
+                  <a:rPr lang="en-US" altLang="ko-KR" sz="3600" b="1" dirty="0" smtClean="0">
+                    <a:solidFill>
+                      <a:srgbClr val="9BB9FE"/>
+                    </a:solidFill>
+                  </a:rPr>
+                  <a:t>-----</a:t>
+                </a:r>
+                <a:endParaRPr lang="en-US" altLang="ko-KR" sz="3600" b="1" dirty="0">
+                  <a:solidFill>
+                    <a:srgbClr val="9BB9FE"/>
+                  </a:solidFill>
+                </a:endParaRPr>
+              </a:p>
+            </p:txBody>
+          </p:sp>
+        </p:grpSp>
+        <p:grpSp>
+          <p:nvGrpSpPr>
+            <p:cNvPr id="99" name="그룹 98"/>
+            <p:cNvGrpSpPr/>
+            <p:nvPr/>
+          </p:nvGrpSpPr>
+          <p:grpSpPr>
+            <a:xfrm>
+              <a:off x="8172450" y="5175250"/>
+              <a:ext cx="752555" cy="735403"/>
+              <a:chOff x="8229600" y="5207000"/>
+              <a:chExt cx="752555" cy="735403"/>
+            </a:xfrm>
+          </p:grpSpPr>
+          <p:sp>
+            <p:nvSpPr>
+              <p:cNvPr id="93" name="뺄셈 기호 92"/>
+              <p:cNvSpPr/>
+              <p:nvPr/>
+            </p:nvSpPr>
+            <p:spPr>
+              <a:xfrm rot="2468983">
+                <a:off x="8546839" y="5539715"/>
+                <a:ext cx="435316" cy="402688"/>
+              </a:xfrm>
+              <a:prstGeom prst="mathMinus">
+                <a:avLst/>
+              </a:prstGeom>
+              <a:solidFill>
+                <a:schemeClr val="bg1"/>
+              </a:solidFill>
+              <a:ln w="38100">
+                <a:solidFill>
+                  <a:srgbClr val="9BB9FE"/>
+                </a:solidFill>
+              </a:ln>
+            </p:spPr>
+            <p:style>
+              <a:lnRef idx="2">
+                <a:schemeClr val="accent1">
+                  <a:shade val="50000"/>
+                </a:schemeClr>
+              </a:lnRef>
+              <a:fillRef idx="1">
+                <a:schemeClr val="accent1"/>
+              </a:fillRef>
+              <a:effectRef idx="0">
+                <a:schemeClr val="accent1"/>
+              </a:effectRef>
+              <a:fontRef idx="minor">
+                <a:schemeClr val="lt1"/>
+              </a:fontRef>
+            </p:style>
+            <p:txBody>
+              <a:bodyPr rtlCol="0" anchor="ctr"/>
+              <a:lstStyle/>
+              <a:p>
+                <a:pPr algn="ctr"/>
+                <a:endParaRPr lang="ko-KR" altLang="en-US"/>
+              </a:p>
+            </p:txBody>
+          </p:sp>
+          <p:sp>
+            <p:nvSpPr>
+              <p:cNvPr id="97" name="타원 96"/>
+              <p:cNvSpPr/>
+              <p:nvPr/>
+            </p:nvSpPr>
+            <p:spPr>
+              <a:xfrm>
+                <a:off x="8229600" y="5207000"/>
+                <a:ext cx="543600" cy="540000"/>
+              </a:xfrm>
+              <a:prstGeom prst="ellipse">
+                <a:avLst/>
+              </a:prstGeom>
+              <a:solidFill>
+                <a:schemeClr val="bg1"/>
+              </a:solidFill>
+              <a:ln w="38100">
+                <a:solidFill>
+                  <a:srgbClr val="9BB9FE"/>
+                </a:solidFill>
+              </a:ln>
+            </p:spPr>
+            <p:style>
+              <a:lnRef idx="2">
+                <a:schemeClr val="accent1">
+                  <a:shade val="50000"/>
+                </a:schemeClr>
+              </a:lnRef>
+              <a:fillRef idx="1">
+                <a:schemeClr val="accent1"/>
+              </a:fillRef>
+              <a:effectRef idx="0">
+                <a:schemeClr val="accent1"/>
+              </a:effectRef>
+              <a:fontRef idx="minor">
+                <a:schemeClr val="lt1"/>
+              </a:fontRef>
+            </p:style>
+            <p:txBody>
+              <a:bodyPr rtlCol="0" anchor="ctr"/>
+              <a:lstStyle/>
+              <a:p>
+                <a:pPr algn="ctr"/>
+                <a:endParaRPr lang="ko-KR" altLang="en-US"/>
+              </a:p>
+            </p:txBody>
+          </p:sp>
+          <p:sp>
+            <p:nvSpPr>
+              <p:cNvPr id="98" name="타원 97"/>
+              <p:cNvSpPr/>
+              <p:nvPr/>
+            </p:nvSpPr>
+            <p:spPr>
+              <a:xfrm>
+                <a:off x="8306687" y="5277100"/>
+                <a:ext cx="396000" cy="396000"/>
+              </a:xfrm>
+              <a:prstGeom prst="ellipse">
+                <a:avLst/>
+              </a:prstGeom>
+              <a:solidFill>
+                <a:schemeClr val="bg1"/>
+              </a:solidFill>
+              <a:ln w="38100">
+                <a:solidFill>
+                  <a:srgbClr val="9BB9FE"/>
+                </a:solidFill>
+              </a:ln>
+            </p:spPr>
+            <p:style>
+              <a:lnRef idx="2">
+                <a:schemeClr val="accent1">
+                  <a:shade val="50000"/>
+                </a:schemeClr>
+              </a:lnRef>
+              <a:fillRef idx="1">
+                <a:schemeClr val="accent1"/>
+              </a:fillRef>
+              <a:effectRef idx="0">
+                <a:schemeClr val="accent1"/>
+              </a:effectRef>
+              <a:fontRef idx="minor">
+                <a:schemeClr val="lt1"/>
+              </a:fontRef>
+            </p:style>
+            <p:txBody>
+              <a:bodyPr rtlCol="0" anchor="ctr"/>
+              <a:lstStyle/>
+              <a:p>
+                <a:pPr algn="ctr"/>
+                <a:endParaRPr lang="ko-KR" altLang="en-US"/>
+              </a:p>
+            </p:txBody>
+          </p:sp>
+        </p:grpSp>
+      </p:grpSp>
     </p:spTree>
     <p:extLst>
       <p:ext uri="{BB962C8B-B14F-4D97-AF65-F5344CB8AC3E}">
@@ -13960,7 +14534,7 @@
 </p:sld>
 </file>
 
-<file path=ppt/slides/slide2.xml><?xml version="1.0" encoding="utf-8"?>
+<file path=ppt/slides/slide3.xml><?xml version="1.0" encoding="utf-8"?>
 <p:sld xmlns:a="http://schemas.openxmlformats.org/drawingml/2006/main" xmlns:r="http://schemas.openxmlformats.org/officeDocument/2006/relationships" xmlns:p="http://schemas.openxmlformats.org/presentationml/2006/main">
   <p:cSld>
     <p:spTree>
@@ -15305,7 +15879,7 @@
 </p:sld>
 </file>
 
-<file path=ppt/slides/slide3.xml><?xml version="1.0" encoding="utf-8"?>
+<file path=ppt/slides/slide4.xml><?xml version="1.0" encoding="utf-8"?>
 <p:sld xmlns:a="http://schemas.openxmlformats.org/drawingml/2006/main" xmlns:r="http://schemas.openxmlformats.org/officeDocument/2006/relationships" xmlns:p="http://schemas.openxmlformats.org/presentationml/2006/main">
   <p:cSld>
     <p:spTree>
@@ -19802,7 +20376,7 @@
 </p:sld>
 </file>
 
-<file path=ppt/slides/slide4.xml><?xml version="1.0" encoding="utf-8"?>
+<file path=ppt/slides/slide5.xml><?xml version="1.0" encoding="utf-8"?>
 <p:sld xmlns:a="http://schemas.openxmlformats.org/drawingml/2006/main" xmlns:r="http://schemas.openxmlformats.org/officeDocument/2006/relationships" xmlns:p="http://schemas.openxmlformats.org/presentationml/2006/main">
   <p:cSld>
     <p:spTree>
@@ -19992,7 +20566,7 @@
 </p:sld>
 </file>
 
-<file path=ppt/slides/slide5.xml><?xml version="1.0" encoding="utf-8"?>
+<file path=ppt/slides/slide6.xml><?xml version="1.0" encoding="utf-8"?>
 <p:sld xmlns:a="http://schemas.openxmlformats.org/drawingml/2006/main" xmlns:r="http://schemas.openxmlformats.org/officeDocument/2006/relationships" xmlns:p="http://schemas.openxmlformats.org/presentationml/2006/main">
   <p:cSld>
     <p:spTree>

</xml_diff>